<commit_message>
feat: complete end-to-end master pipeline, cross-platform path sanitization, and HPC PBS submission package
</commit_message>
<xml_diff>
--- a/Figures/My_Figure/Figures.pptx
+++ b/Figures/My_Figure/Figures.pptx
@@ -7,6 +7,9 @@
   <p:sldIdLst>
     <p:sldId id="257" r:id="rId2"/>
     <p:sldId id="258" r:id="rId3"/>
+    <p:sldId id="259" r:id="rId4"/>
+    <p:sldId id="261" r:id="rId5"/>
+    <p:sldId id="260" r:id="rId6"/>
   </p:sldIdLst>
   <p:sldSz cx="9601200" cy="5400675"/>
   <p:notesSz cx="9144000" cy="6858000"/>
@@ -105,6 +108,11 @@
       </a:defRPr>
     </a:lvl9pPr>
   </p:defaultTextStyle>
+  <p:extLst>
+    <p:ext uri="{EFAFB233-063F-42B5-8137-9DF3F51BA10A}">
+      <p15:sldGuideLst xmlns:p15="http://schemas.microsoft.com/office/powerpoint/2012/main"/>
+    </p:ext>
+  </p:extLst>
 </p:presentation>
 </file>
 
@@ -239,7 +247,7 @@
           <a:p>
             <a:fld id="{C7A09CBA-B56B-413D-AADC-2E908D664F4B}" type="datetimeFigureOut">
               <a:rPr lang="en-SG" smtClean="0"/>
-              <a:t>3/9/2026</a:t>
+              <a:t>7/9/2026</a:t>
             </a:fld>
             <a:endParaRPr lang="en-SG"/>
           </a:p>
@@ -409,7 +417,7 @@
           <a:p>
             <a:fld id="{C7A09CBA-B56B-413D-AADC-2E908D664F4B}" type="datetimeFigureOut">
               <a:rPr lang="en-SG" smtClean="0"/>
-              <a:t>3/9/2026</a:t>
+              <a:t>7/9/2026</a:t>
             </a:fld>
             <a:endParaRPr lang="en-SG"/>
           </a:p>
@@ -589,7 +597,7 @@
           <a:p>
             <a:fld id="{C7A09CBA-B56B-413D-AADC-2E908D664F4B}" type="datetimeFigureOut">
               <a:rPr lang="en-SG" smtClean="0"/>
-              <a:t>3/9/2026</a:t>
+              <a:t>7/9/2026</a:t>
             </a:fld>
             <a:endParaRPr lang="en-SG"/>
           </a:p>
@@ -759,7 +767,7 @@
           <a:p>
             <a:fld id="{C7A09CBA-B56B-413D-AADC-2E908D664F4B}" type="datetimeFigureOut">
               <a:rPr lang="en-SG" smtClean="0"/>
-              <a:t>3/9/2026</a:t>
+              <a:t>7/9/2026</a:t>
             </a:fld>
             <a:endParaRPr lang="en-SG"/>
           </a:p>
@@ -1005,7 +1013,7 @@
           <a:p>
             <a:fld id="{C7A09CBA-B56B-413D-AADC-2E908D664F4B}" type="datetimeFigureOut">
               <a:rPr lang="en-SG" smtClean="0"/>
-              <a:t>3/9/2026</a:t>
+              <a:t>7/9/2026</a:t>
             </a:fld>
             <a:endParaRPr lang="en-SG"/>
           </a:p>
@@ -1237,7 +1245,7 @@
           <a:p>
             <a:fld id="{C7A09CBA-B56B-413D-AADC-2E908D664F4B}" type="datetimeFigureOut">
               <a:rPr lang="en-SG" smtClean="0"/>
-              <a:t>3/9/2026</a:t>
+              <a:t>7/9/2026</a:t>
             </a:fld>
             <a:endParaRPr lang="en-SG"/>
           </a:p>
@@ -1604,7 +1612,7 @@
           <a:p>
             <a:fld id="{C7A09CBA-B56B-413D-AADC-2E908D664F4B}" type="datetimeFigureOut">
               <a:rPr lang="en-SG" smtClean="0"/>
-              <a:t>3/9/2026</a:t>
+              <a:t>7/9/2026</a:t>
             </a:fld>
             <a:endParaRPr lang="en-SG"/>
           </a:p>
@@ -1722,7 +1730,7 @@
           <a:p>
             <a:fld id="{C7A09CBA-B56B-413D-AADC-2E908D664F4B}" type="datetimeFigureOut">
               <a:rPr lang="en-SG" smtClean="0"/>
-              <a:t>3/9/2026</a:t>
+              <a:t>7/9/2026</a:t>
             </a:fld>
             <a:endParaRPr lang="en-SG"/>
           </a:p>
@@ -1817,7 +1825,7 @@
           <a:p>
             <a:fld id="{C7A09CBA-B56B-413D-AADC-2E908D664F4B}" type="datetimeFigureOut">
               <a:rPr lang="en-SG" smtClean="0"/>
-              <a:t>3/9/2026</a:t>
+              <a:t>7/9/2026</a:t>
             </a:fld>
             <a:endParaRPr lang="en-SG"/>
           </a:p>
@@ -2094,7 +2102,7 @@
           <a:p>
             <a:fld id="{C7A09CBA-B56B-413D-AADC-2E908D664F4B}" type="datetimeFigureOut">
               <a:rPr lang="en-SG" smtClean="0"/>
-              <a:t>3/9/2026</a:t>
+              <a:t>7/9/2026</a:t>
             </a:fld>
             <a:endParaRPr lang="en-SG"/>
           </a:p>
@@ -2351,7 +2359,7 @@
           <a:p>
             <a:fld id="{C7A09CBA-B56B-413D-AADC-2E908D664F4B}" type="datetimeFigureOut">
               <a:rPr lang="en-SG" smtClean="0"/>
-              <a:t>3/9/2026</a:t>
+              <a:t>7/9/2026</a:t>
             </a:fld>
             <a:endParaRPr lang="en-SG"/>
           </a:p>
@@ -2564,7 +2572,7 @@
           <a:p>
             <a:fld id="{C7A09CBA-B56B-413D-AADC-2E908D664F4B}" type="datetimeFigureOut">
               <a:rPr lang="en-SG" smtClean="0"/>
-              <a:t>3/9/2026</a:t>
+              <a:t>7/9/2026</a:t>
             </a:fld>
             <a:endParaRPr lang="en-SG"/>
           </a:p>
@@ -3092,7 +3100,7 @@
         </p:nvGrpSpPr>
         <p:grpSpPr>
           <a:xfrm>
-            <a:off x="2069831" y="1076093"/>
+            <a:off x="1627871" y="916073"/>
             <a:ext cx="4377054" cy="3065607"/>
             <a:chOff x="941118" y="1150794"/>
             <a:chExt cx="4377054" cy="3065607"/>
@@ -5966,8 +5974,8 @@
               </a:fontRef>
             </p:style>
           </p:cxnSp>
-          <mc:AlternateContent xmlns:mc="http://schemas.openxmlformats.org/markup-compatibility/2006">
-            <mc:Choice xmlns:a14="http://schemas.microsoft.com/office/drawing/2010/main" Requires="a14">
+          <mc:AlternateContent xmlns:mc="http://schemas.openxmlformats.org/markup-compatibility/2006" xmlns:a14="http://schemas.microsoft.com/office/drawing/2010/main">
+            <mc:Choice Requires="a14">
               <p:sp>
                 <p:nvSpPr>
                   <p:cNvPr id="62" name="TextBox 61">
@@ -5999,6 +6007,7 @@
                   </a:bodyPr>
                   <a:lstStyle/>
                   <a:p>
+                    <a:pPr/>
                     <a14:m>
                       <m:oMathPara xmlns:m="http://schemas.openxmlformats.org/officeDocument/2006/math">
                         <m:oMath>
@@ -6042,7 +6051,7 @@
                 </p:txBody>
               </p:sp>
             </mc:Choice>
-            <mc:Fallback>
+            <mc:Fallback xmlns="">
               <p:sp>
                 <p:nvSpPr>
                   <p:cNvPr id="62" name="TextBox 61">
@@ -6068,7 +6077,7 @@
                   <a:blipFill>
                     <a:blip r:embed="rId2"/>
                     <a:stretch>
-                      <a:fillRect l="-5455" r="-9091" b="-3846"/>
+                      <a:fillRect l="-7407" r="-11111" b="-8000"/>
                     </a:stretch>
                   </a:blipFill>
                   <a:ln>
@@ -6867,8 +6876,8 @@
               </p:style>
             </p:cxnSp>
           </p:grpSp>
-          <mc:AlternateContent xmlns:mc="http://schemas.openxmlformats.org/markup-compatibility/2006">
-            <mc:Choice xmlns:a14="http://schemas.microsoft.com/office/drawing/2010/main" Requires="a14">
+          <mc:AlternateContent xmlns:mc="http://schemas.openxmlformats.org/markup-compatibility/2006" xmlns:a14="http://schemas.microsoft.com/office/drawing/2010/main">
+            <mc:Choice Requires="a14">
               <p:sp>
                 <p:nvSpPr>
                   <p:cNvPr id="93" name="TextBox 92">
@@ -6914,6 +6923,7 @@
                     </a:lvl1pPr>
                   </a:lstStyle>
                   <a:p>
+                    <a:pPr/>
                     <a14:m>
                       <m:oMathPara xmlns:m="http://schemas.openxmlformats.org/officeDocument/2006/math">
                         <m:oMath>
@@ -6924,6 +6934,7 @@
                                   <a:lumMod val="75000"/>
                                 </a:schemeClr>
                               </a:solidFill>
+                              <a:latin typeface="Cambria Math" panose="02040503050406030204" pitchFamily="18" charset="0"/>
                             </a:rPr>
                             <m:t>𝑞</m:t>
                           </m:r>
@@ -6934,6 +6945,7 @@
                                   <a:lumMod val="75000"/>
                                 </a:schemeClr>
                               </a:solidFill>
+                              <a:latin typeface="Cambria Math" panose="02040503050406030204" pitchFamily="18" charset="0"/>
                             </a:rPr>
                             <m:t>′′</m:t>
                           </m:r>
@@ -6951,7 +6963,7 @@
                 </p:txBody>
               </p:sp>
             </mc:Choice>
-            <mc:Fallback>
+            <mc:Fallback xmlns="">
               <p:sp>
                 <p:nvSpPr>
                   <p:cNvPr id="93" name="TextBox 92">
@@ -6977,7 +6989,7 @@
                   <a:blipFill>
                     <a:blip r:embed="rId3"/>
                     <a:stretch>
-                      <a:fillRect l="-22222" r="-14815" b="-23077"/>
+                      <a:fillRect l="-18519" r="-18519" b="-28000"/>
                     </a:stretch>
                   </a:blipFill>
                   <a:ln>
@@ -7477,8 +7489,8 @@
               </a:p>
             </p:txBody>
           </p:sp>
-          <mc:AlternateContent xmlns:mc="http://schemas.openxmlformats.org/markup-compatibility/2006">
-            <mc:Choice xmlns:a14="http://schemas.microsoft.com/office/drawing/2010/main" Requires="a14">
+          <mc:AlternateContent xmlns:mc="http://schemas.openxmlformats.org/markup-compatibility/2006" xmlns:a14="http://schemas.microsoft.com/office/drawing/2010/main">
+            <mc:Choice Requires="a14">
               <p:sp>
                 <p:nvSpPr>
                   <p:cNvPr id="129" name="TextBox 128">
@@ -7510,6 +7522,7 @@
                   </a:bodyPr>
                   <a:lstStyle/>
                   <a:p>
+                    <a:pPr/>
                     <a14:m>
                       <m:oMathPara xmlns:m="http://schemas.openxmlformats.org/officeDocument/2006/math">
                         <m:oMath>
@@ -7553,7 +7566,7 @@
                 </p:txBody>
               </p:sp>
             </mc:Choice>
-            <mc:Fallback>
+            <mc:Fallback xmlns="">
               <p:sp>
                 <p:nvSpPr>
                   <p:cNvPr id="129" name="TextBox 128">
@@ -7579,7 +7592,7 @@
                   <a:blipFill>
                     <a:blip r:embed="rId4"/>
                     <a:stretch>
-                      <a:fillRect l="-5455" r="-10909" b="-4000"/>
+                      <a:fillRect l="-7273" r="-9091" b="-3846"/>
                     </a:stretch>
                   </a:blipFill>
                   <a:ln>
@@ -7601,8 +7614,8 @@
               </p:sp>
             </mc:Fallback>
           </mc:AlternateContent>
-          <mc:AlternateContent xmlns:mc="http://schemas.openxmlformats.org/markup-compatibility/2006">
-            <mc:Choice xmlns:a14="http://schemas.microsoft.com/office/drawing/2010/main" Requires="a14">
+          <mc:AlternateContent xmlns:mc="http://schemas.openxmlformats.org/markup-compatibility/2006" xmlns:a14="http://schemas.microsoft.com/office/drawing/2010/main">
+            <mc:Choice Requires="a14">
               <p:sp>
                 <p:nvSpPr>
                   <p:cNvPr id="130" name="TextBox 129">
@@ -7634,6 +7647,7 @@
                   </a:bodyPr>
                   <a:lstStyle/>
                   <a:p>
+                    <a:pPr/>
                     <a14:m>
                       <m:oMathPara xmlns:m="http://schemas.openxmlformats.org/officeDocument/2006/math">
                         <m:oMath>
@@ -7677,7 +7691,7 @@
                 </p:txBody>
               </p:sp>
             </mc:Choice>
-            <mc:Fallback>
+            <mc:Fallback xmlns="">
               <p:sp>
                 <p:nvSpPr>
                   <p:cNvPr id="130" name="TextBox 129">
@@ -7703,7 +7717,7 @@
                   <a:blipFill>
                     <a:blip r:embed="rId5"/>
                     <a:stretch>
-                      <a:fillRect l="-3636" r="-10909" b="-8000"/>
+                      <a:fillRect l="-5455" r="-9091" b="-4000"/>
                     </a:stretch>
                   </a:blipFill>
                   <a:ln>
@@ -10470,6 +10484,239 @@
 </p:sld>
 </file>
 
+<file path=ppt/slides/slide3.xml><?xml version="1.0" encoding="utf-8"?>
+<p:sld xmlns:a="http://schemas.openxmlformats.org/drawingml/2006/main" xmlns:r="http://schemas.openxmlformats.org/officeDocument/2006/relationships" xmlns:p="http://schemas.openxmlformats.org/presentationml/2006/main">
+  <p:cSld>
+    <p:spTree>
+      <p:nvGrpSpPr>
+        <p:cNvPr id="1" name=""/>
+        <p:cNvGrpSpPr/>
+        <p:nvPr/>
+      </p:nvGrpSpPr>
+      <p:grpSpPr>
+        <a:xfrm>
+          <a:off x="0" y="0"/>
+          <a:ext cx="0" cy="0"/>
+          <a:chOff x="0" y="0"/>
+          <a:chExt cx="0" cy="0"/>
+        </a:xfrm>
+      </p:grpSpPr>
+      <p:grpSp>
+        <p:nvGrpSpPr>
+          <p:cNvPr id="2521" name="Group 2520">
+            <a:extLst>
+              <a:ext uri="{FF2B5EF4-FFF2-40B4-BE49-F238E27FC236}">
+                <a16:creationId xmlns:a16="http://schemas.microsoft.com/office/drawing/2014/main" id="{707B8630-2557-CF36-C264-14F29576427A}"/>
+              </a:ext>
+            </a:extLst>
+          </p:cNvPr>
+          <p:cNvGrpSpPr/>
+          <p:nvPr/>
+        </p:nvGrpSpPr>
+        <p:grpSpPr>
+          <a:xfrm>
+            <a:off x="2476696" y="0"/>
+            <a:ext cx="4647807" cy="5400675"/>
+            <a:chOff x="2476696" y="0"/>
+            <a:chExt cx="4647807" cy="5400675"/>
+          </a:xfrm>
+        </p:grpSpPr>
+        <p:pic>
+          <p:nvPicPr>
+            <p:cNvPr id="2387" name="Graphic 2386">
+              <a:extLst>
+                <a:ext uri="{FF2B5EF4-FFF2-40B4-BE49-F238E27FC236}">
+                  <a16:creationId xmlns:a16="http://schemas.microsoft.com/office/drawing/2014/main" id="{73F86B5C-84B1-14F6-B5C4-48C5A7BD84EB}"/>
+                </a:ext>
+              </a:extLst>
+            </p:cNvPr>
+            <p:cNvPicPr>
+              <a:picLocks noChangeAspect="1"/>
+            </p:cNvPicPr>
+            <p:nvPr/>
+          </p:nvPicPr>
+          <p:blipFill>
+            <a:blip>
+              <a:extLst>
+                <a:ext uri="{96DAC541-7B7A-43D3-8B79-37D633B846F1}">
+                  <asvg:svgBlip xmlns:asvg="http://schemas.microsoft.com/office/drawing/2016/SVG/main" r:embed="rId2"/>
+                </a:ext>
+              </a:extLst>
+            </a:blip>
+            <a:stretch>
+              <a:fillRect/>
+            </a:stretch>
+          </p:blipFill>
+          <p:spPr>
+            <a:xfrm>
+              <a:off x="2476696" y="0"/>
+              <a:ext cx="4647807" cy="5400675"/>
+            </a:xfrm>
+            <a:prstGeom prst="rect">
+              <a:avLst/>
+            </a:prstGeom>
+          </p:spPr>
+        </p:pic>
+        <p:pic>
+          <p:nvPicPr>
+            <p:cNvPr id="2520" name="Graphic 2519">
+              <a:extLst>
+                <a:ext uri="{FF2B5EF4-FFF2-40B4-BE49-F238E27FC236}">
+                  <a16:creationId xmlns:a16="http://schemas.microsoft.com/office/drawing/2014/main" id="{5EBA8F40-ED62-CCF7-1059-5C84C8A75FDD}"/>
+                </a:ext>
+              </a:extLst>
+            </p:cNvPr>
+            <p:cNvPicPr>
+              <a:picLocks noChangeAspect="1"/>
+            </p:cNvPicPr>
+            <p:nvPr/>
+          </p:nvPicPr>
+          <p:blipFill>
+            <a:blip>
+              <a:extLst>
+                <a:ext uri="{96DAC541-7B7A-43D3-8B79-37D633B846F1}">
+                  <asvg:svgBlip xmlns:asvg="http://schemas.microsoft.com/office/drawing/2016/SVG/main" r:embed="rId3"/>
+                </a:ext>
+              </a:extLst>
+            </a:blip>
+            <a:stretch>
+              <a:fillRect/>
+            </a:stretch>
+          </p:blipFill>
+          <p:spPr>
+            <a:xfrm>
+              <a:off x="2621692" y="167640"/>
+              <a:ext cx="2178908" cy="1524000"/>
+            </a:xfrm>
+            <a:prstGeom prst="rect">
+              <a:avLst/>
+            </a:prstGeom>
+          </p:spPr>
+        </p:pic>
+      </p:grpSp>
+    </p:spTree>
+    <p:extLst>
+      <p:ext uri="{BB962C8B-B14F-4D97-AF65-F5344CB8AC3E}">
+        <p14:creationId xmlns:p14="http://schemas.microsoft.com/office/powerpoint/2010/main" val="162141046"/>
+      </p:ext>
+    </p:extLst>
+  </p:cSld>
+  <p:clrMapOvr>
+    <a:masterClrMapping/>
+  </p:clrMapOvr>
+</p:sld>
+</file>
+
+<file path=ppt/slides/slide4.xml><?xml version="1.0" encoding="utf-8"?>
+<p:sld xmlns:a="http://schemas.openxmlformats.org/drawingml/2006/main" xmlns:r="http://schemas.openxmlformats.org/officeDocument/2006/relationships" xmlns:p="http://schemas.openxmlformats.org/presentationml/2006/main">
+  <p:cSld>
+    <p:spTree>
+      <p:nvGrpSpPr>
+        <p:cNvPr id="1" name=""/>
+        <p:cNvGrpSpPr/>
+        <p:nvPr/>
+      </p:nvGrpSpPr>
+      <p:grpSpPr>
+        <a:xfrm>
+          <a:off x="0" y="0"/>
+          <a:ext cx="0" cy="0"/>
+          <a:chOff x="0" y="0"/>
+          <a:chExt cx="0" cy="0"/>
+        </a:xfrm>
+      </p:grpSpPr>
+      <p:sp>
+        <p:nvSpPr>
+          <p:cNvPr id="2" name="Title 1">
+            <a:extLst>
+              <a:ext uri="{FF2B5EF4-FFF2-40B4-BE49-F238E27FC236}">
+                <a16:creationId xmlns:a16="http://schemas.microsoft.com/office/drawing/2014/main" id="{B7E4BD49-4AFE-1722-7F07-E4E38634BBF8}"/>
+              </a:ext>
+            </a:extLst>
+          </p:cNvPr>
+          <p:cNvSpPr>
+            <a:spLocks noGrp="1"/>
+          </p:cNvSpPr>
+          <p:nvPr>
+            <p:ph type="title"/>
+          </p:nvPr>
+        </p:nvSpPr>
+        <p:spPr/>
+        <p:txBody>
+          <a:bodyPr/>
+          <a:lstStyle/>
+          <a:p>
+            <a:endParaRPr lang="en-SG"/>
+          </a:p>
+        </p:txBody>
+      </p:sp>
+      <p:sp>
+        <p:nvSpPr>
+          <p:cNvPr id="3" name="Content Placeholder 2">
+            <a:extLst>
+              <a:ext uri="{FF2B5EF4-FFF2-40B4-BE49-F238E27FC236}">
+                <a16:creationId xmlns:a16="http://schemas.microsoft.com/office/drawing/2014/main" id="{9EE6DA33-BEBA-6B1A-D483-C853E7B065A9}"/>
+              </a:ext>
+            </a:extLst>
+          </p:cNvPr>
+          <p:cNvSpPr>
+            <a:spLocks noGrp="1"/>
+          </p:cNvSpPr>
+          <p:nvPr>
+            <p:ph idx="1"/>
+          </p:nvPr>
+        </p:nvSpPr>
+        <p:spPr/>
+        <p:txBody>
+          <a:bodyPr/>
+          <a:lstStyle/>
+          <a:p>
+            <a:endParaRPr lang="en-SG"/>
+          </a:p>
+        </p:txBody>
+      </p:sp>
+    </p:spTree>
+    <p:extLst>
+      <p:ext uri="{BB962C8B-B14F-4D97-AF65-F5344CB8AC3E}">
+        <p14:creationId xmlns:p14="http://schemas.microsoft.com/office/powerpoint/2010/main" val="3030290216"/>
+      </p:ext>
+    </p:extLst>
+  </p:cSld>
+  <p:clrMapOvr>
+    <a:masterClrMapping/>
+  </p:clrMapOvr>
+</p:sld>
+</file>
+
+<file path=ppt/slides/slide5.xml><?xml version="1.0" encoding="utf-8"?>
+<p:sld xmlns:a="http://schemas.openxmlformats.org/drawingml/2006/main" xmlns:r="http://schemas.openxmlformats.org/officeDocument/2006/relationships" xmlns:p="http://schemas.openxmlformats.org/presentationml/2006/main">
+  <p:cSld>
+    <p:spTree>
+      <p:nvGrpSpPr>
+        <p:cNvPr id="1" name=""/>
+        <p:cNvGrpSpPr/>
+        <p:nvPr/>
+      </p:nvGrpSpPr>
+      <p:grpSpPr>
+        <a:xfrm>
+          <a:off x="0" y="0"/>
+          <a:ext cx="0" cy="0"/>
+          <a:chOff x="0" y="0"/>
+          <a:chExt cx="0" cy="0"/>
+        </a:xfrm>
+      </p:grpSpPr>
+    </p:spTree>
+    <p:extLst>
+      <p:ext uri="{BB962C8B-B14F-4D97-AF65-F5344CB8AC3E}">
+        <p14:creationId xmlns:p14="http://schemas.microsoft.com/office/powerpoint/2010/main" val="1717931822"/>
+      </p:ext>
+    </p:extLst>
+  </p:cSld>
+  <p:clrMapOvr>
+    <a:masterClrMapping/>
+  </p:clrMapOvr>
+</p:sld>
+</file>
+
 <file path=ppt/theme/theme1.xml><?xml version="1.0" encoding="utf-8"?>
 <a:theme xmlns:a="http://schemas.openxmlformats.org/drawingml/2006/main" name="Office Theme">
   <a:themeElements>

</xml_diff>